<commit_message>
AutomaTivio: posts com logos horizontais e Infra Plus CDI; abertura automática dos ALT; post sem casa decimal
- Posts de Crédito Privado e Estruturado: logos horizontais de assets/logos.
- Post de Crédito Privado: card do Infra Plus CDI (página 8); sem 12M, o
  destaque vira "Desde o início".
- Boxes de Rentabilidade dos posts sem casa decimal ("100%"), exceto Infra
  Plus e Infra Plus CDI.
- ALT 180, 90 e Light (`abertura: alt`): o 1º parágrafo do comentário é a
  abertura padrão com os números da tabela; o anualizado é o "%" desde o
  início da tabela (ALT 180 de setembro: 130,15%).

Co-Authored-By: Claude Opus 5.5 <noreply@anthropic.com>
</commit_message>
<xml_diff>
--- a/AutomaTivio/saida/2026-09/pptx/Tivio ALT 90 - Relatório de Gestão - Setembro 2026.pptx
+++ b/AutomaTivio/saida/2026-09/pptx/Tivio ALT 90 - Relatório de Gestão - Setembro 2026.pptx
@@ -5444,7 +5444,7 @@
         <p:spPr>
           <a:xfrm>
             <a:off x="415800" y="7998598"/>
-            <a:ext cx="6728400" cy="267553"/>
+            <a:ext cx="6728400" cy="265426"/>
           </a:xfrm>
           <a:prstGeom prst="rect">
             <a:avLst/>
@@ -5457,17 +5457,17 @@
           <a:p>
             <a:pPr algn="just">
               <a:lnSpc>
-                <a:spcPts val="1036"/>
-              </a:lnSpc>
-            </a:pPr>
-            <a:r>
-              <a:rPr sz="878" b="0" i="0">
+                <a:spcPts val="1018"/>
+              </a:lnSpc>
+            </a:pPr>
+            <a:r>
+              <a:rPr sz="863" b="0" i="0">
                 <a:solidFill>
                   <a:srgbClr val="222222"/>
                 </a:solidFill>
                 <a:latin typeface="Versos"/>
               </a:rPr>
-              <a:t>O Tivio ALT 90 registrou rentabilidade de 1,17% no mês, equivalente a 108,27% do CDI no período. Desde o início da estratégia, o fundo acumula retorno de 22,67%, frente a 19,70% do CDI, o que corresponde a um desempenho anualizado de 115% do CDI.</a:t>
+              <a:t>O Tivio ALT 90 registrou rentabilidade de 1,17% no mês, equivalente a 108,27% do CDI no período. Desde o início da estratégia, o fundo acumula retorno de 22,67%, frente a 19,70% do CDI, o que corresponde a um desempenho anualizado de 115,11% do CDI.</a:t>
             </a:r>
           </a:p>
         </p:txBody>
@@ -5480,8 +5480,8 @@
         </p:nvSpPr>
         <p:spPr>
           <a:xfrm>
-            <a:off x="415800" y="8328403"/>
-            <a:ext cx="6728400" cy="793445"/>
+            <a:off x="415800" y="8322969"/>
+            <a:ext cx="6728400" cy="782814"/>
           </a:xfrm>
           <a:prstGeom prst="rect">
             <a:avLst/>
@@ -5494,11 +5494,11 @@
           <a:p>
             <a:pPr algn="just">
               <a:lnSpc>
-                <a:spcPts val="1036"/>
-              </a:lnSpc>
-            </a:pPr>
-            <a:r>
-              <a:rPr sz="878" b="0" i="0">
+                <a:spcPts val="1018"/>
+              </a:lnSpc>
+            </a:pPr>
+            <a:r>
+              <a:rPr sz="863" b="0" i="0">
                 <a:solidFill>
                   <a:srgbClr val="222222"/>
                 </a:solidFill>
@@ -5517,8 +5517,8 @@
         </p:nvSpPr>
         <p:spPr>
           <a:xfrm>
-            <a:off x="415800" y="9184100"/>
-            <a:ext cx="6728400" cy="661972"/>
+            <a:off x="415800" y="9164728"/>
+            <a:ext cx="6728400" cy="653467"/>
           </a:xfrm>
           <a:prstGeom prst="rect">
             <a:avLst/>
@@ -5531,11 +5531,11 @@
           <a:p>
             <a:pPr algn="just">
               <a:lnSpc>
-                <a:spcPts val="1036"/>
-              </a:lnSpc>
-            </a:pPr>
-            <a:r>
-              <a:rPr sz="878" b="0" i="0">
+                <a:spcPts val="1018"/>
+              </a:lnSpc>
+            </a:pPr>
+            <a:r>
+              <a:rPr sz="863" b="0" i="0">
                 <a:solidFill>
                   <a:srgbClr val="222222"/>
                 </a:solidFill>

</xml_diff>